<commit_message>
feat(agents): natively integrate Google ADK and align architecture with MedQuAD corpus
- Wire google.adk.Agent instances across RootOrchestrator, ResearcherAgent, and ReviewerAgent
- Register medquad_search_tool and medquad_citation_verifier_tool with ADK typed signatures
- Export root_agent and initialize AdkRunner with InMemorySessionService
- Remove mock clinical DB artifacts and focus grounding purely on NIH MedQuAD corpus and Vertex AI Search
- Update docs, presentation decks, slides, and architecture diagrams to reflect MedQuAD grounding
- Add Workload Identity Federation (WIF) configuration in terraform/wif.tf
- Add unit tests for ADK supervisor-worker hierarchy and tool registrations (44/44 passed)
</commit_message>
<xml_diff>
--- a/docs/medquad_architecture_diagram.pptx
+++ b/docs/medquad_architecture_diagram.pptx
@@ -527,7 +527,7 @@
           <a:p/>
           <a:p>
             <a:r>
-              <a:t>4. Grounding: Researcher retrieves 500-token semantic chunks from Vertex AI Search and reference lab ranges from ClinicalDBTool.</a:t>
+              <a:t>4. Grounding: Researcher retrieves 500-token semantic chunks from Vertex AI Search from Vertex AI Search.</a:t>
             </a:r>
           </a:p>
           <a:p/>
@@ -5756,7 +5756,7 @@
               </a:defRPr>
             </a:pPr>
             <a:r>
-              <a:t>Clinical Reference DB</a:t>
+              <a:t>Cloud Storage (GCS)</a:t>
             </a:r>
           </a:p>
           <a:p>
@@ -5772,7 +5772,7 @@
               </a:defRPr>
             </a:pPr>
             <a:r>
-              <a:t>Diagnostic Biomarkers &amp; Labs</a:t>
+              <a:t>Corpus &amp; Session Store</a:t>
             </a:r>
           </a:p>
           <a:p>
@@ -5788,7 +5788,7 @@
               </a:defRPr>
             </a:pPr>
             <a:r>
-              <a:t>•  Standard laboratory reference ranges</a:t>
+              <a:t>•  19,204 preprocessed chunks</a:t>
             </a:r>
           </a:p>
           <a:p>

</xml_diff>